<commit_message>
Ocultar prototipo navegable en Presentacion y usar logo real de Correo Argentino
Elimina toda referencia a "prototipo"/"wireframe" en el modulo de
Presentacion (HTML y PPTX) por pedido del cliente interno; conserva el
boton "Volver al hub" en el HTML para navegacion interna. Reemplaza los
badges placeholder "CA" por el isologo real de Correo Argentino en el
Hub, prototipo y HTML de presentacion. Agrega glosario de dominio
(T&T, HH, Mosaic, P80, Office Core) y actualiza el estado del proyecto.

Co-Authored-By: Claude Sonnet 5 <noreply@anthropic.com>
</commit_message>
<xml_diff>
--- a/Documents/Propuesta-1-vs-Propuesta-2.pptx
+++ b/Documents/Propuesta-1-vs-Propuesta-2.pptx
@@ -6153,7 +6153,7 @@
         <p:spPr>
           <a:xfrm>
             <a:off x="777240" y="2103120"/>
-            <a:ext cx="3401568" cy="1691640"/>
+            <a:ext cx="5175504" cy="1691640"/>
           </a:xfrm>
           <a:prstGeom prst="roundRect">
             <a:avLst>
@@ -6234,7 +6234,7 @@
         <p:spPr>
           <a:xfrm>
             <a:off x="960120" y="2724912"/>
-            <a:ext cx="3035808" cy="320040"/>
+            <a:ext cx="4809744" cy="320040"/>
           </a:xfrm>
           <a:prstGeom prst="rect">
             <a:avLst/>
@@ -6258,7 +6258,7 @@
                 <a:ea typeface="Arial" pitchFamily="34" charset="-122"/>
                 <a:cs typeface="Arial" pitchFamily="34" charset="-120"/>
               </a:rPr>
-              <a:t>Asimetría</a:t>
+              <a:t>Mosaic</a:t>
             </a:r>
             <a:endParaRPr lang="en-US" sz="1350" dirty="0"/>
           </a:p>
@@ -6273,7 +6273,7 @@
         <p:spPr>
           <a:xfrm>
             <a:off x="960120" y="3035808"/>
-            <a:ext cx="3035808" cy="640080"/>
+            <a:ext cx="4809744" cy="640080"/>
           </a:xfrm>
           <a:prstGeom prst="rect">
             <a:avLst/>
@@ -6300,7 +6300,7 @@
                 <a:ea typeface="Calibri" pitchFamily="34" charset="-122"/>
                 <a:cs typeface="Calibri" pitchFamily="34" charset="-120"/>
               </a:rPr>
-              <a:t>La Propuesta 1 tiene prototipo navegable; la 2 solo existe en papel.</a:t>
+              <a:t>Solo lo sostiene el documento deprecado.</a:t>
             </a:r>
             <a:endParaRPr lang="en-US" sz="1050" dirty="0"/>
           </a:p>
@@ -6314,8 +6314,8 @@
         </p:nvSpPr>
         <p:spPr>
           <a:xfrm>
-            <a:off x="4379976" y="2103120"/>
-            <a:ext cx="3401568" cy="1691640"/>
+            <a:off x="6208776" y="2103120"/>
+            <a:ext cx="5175504" cy="1691640"/>
           </a:xfrm>
           <a:prstGeom prst="roundRect">
             <a:avLst>
@@ -6336,7 +6336,7 @@
         </p:nvSpPr>
         <p:spPr>
           <a:xfrm>
-            <a:off x="4562856" y="2267712"/>
+            <a:off x="6391656" y="2267712"/>
             <a:ext cx="347472" cy="347472"/>
           </a:xfrm>
           <a:prstGeom prst="ellipse">
@@ -6356,7 +6356,7 @@
         </p:nvSpPr>
         <p:spPr>
           <a:xfrm>
-            <a:off x="4562856" y="2267712"/>
+            <a:off x="6391656" y="2267712"/>
             <a:ext cx="347472" cy="347472"/>
           </a:xfrm>
           <a:prstGeom prst="rect">
@@ -6395,8 +6395,8 @@
         </p:nvSpPr>
         <p:spPr>
           <a:xfrm>
-            <a:off x="4562856" y="2724912"/>
-            <a:ext cx="3035808" cy="320040"/>
+            <a:off x="6391656" y="2724912"/>
+            <a:ext cx="4809744" cy="320040"/>
           </a:xfrm>
           <a:prstGeom prst="rect">
             <a:avLst/>
@@ -6420,7 +6420,7 @@
                 <a:ea typeface="Arial" pitchFamily="34" charset="-122"/>
                 <a:cs typeface="Arial" pitchFamily="34" charset="-120"/>
               </a:rPr>
-              <a:t>Mosaic</a:t>
+              <a:t>Historial y Supervisor</a:t>
             </a:r>
             <a:endParaRPr lang="en-US" sz="1350" dirty="0"/>
           </a:p>
@@ -6434,8 +6434,8 @@
         </p:nvSpPr>
         <p:spPr>
           <a:xfrm>
-            <a:off x="4562856" y="3035808"/>
-            <a:ext cx="3035808" cy="640080"/>
+            <a:off x="6391656" y="3035808"/>
+            <a:ext cx="4809744" cy="640080"/>
           </a:xfrm>
           <a:prstGeom prst="rect">
             <a:avLst/>
@@ -6462,7 +6462,7 @@
                 <a:ea typeface="Calibri" pitchFamily="34" charset="-122"/>
                 <a:cs typeface="Calibri" pitchFamily="34" charset="-120"/>
               </a:rPr>
-              <a:t>Solo lo sostiene el documento deprecado.</a:t>
+              <a:t>Ninguna propuesta los menciona.</a:t>
             </a:r>
             <a:endParaRPr lang="en-US" sz="1050" dirty="0"/>
           </a:p>
@@ -6476,8 +6476,8 @@
         </p:nvSpPr>
         <p:spPr>
           <a:xfrm>
-            <a:off x="7982712" y="2103120"/>
-            <a:ext cx="3401568" cy="1691640"/>
+            <a:off x="777240" y="4050792"/>
+            <a:ext cx="5175504" cy="1691640"/>
           </a:xfrm>
           <a:prstGeom prst="roundRect">
             <a:avLst>
@@ -6498,7 +6498,7 @@
         </p:nvSpPr>
         <p:spPr>
           <a:xfrm>
-            <a:off x="8165592" y="2267712"/>
+            <a:off x="960120" y="4215384"/>
             <a:ext cx="347472" cy="347472"/>
           </a:xfrm>
           <a:prstGeom prst="ellipse">
@@ -6518,7 +6518,7 @@
         </p:nvSpPr>
         <p:spPr>
           <a:xfrm>
-            <a:off x="8165592" y="2267712"/>
+            <a:off x="960120" y="4215384"/>
             <a:ext cx="347472" cy="347472"/>
           </a:xfrm>
           <a:prstGeom prst="rect">
@@ -6557,8 +6557,8 @@
         </p:nvSpPr>
         <p:spPr>
           <a:xfrm>
-            <a:off x="8165592" y="2724912"/>
-            <a:ext cx="3035808" cy="320040"/>
+            <a:off x="960120" y="4672584"/>
+            <a:ext cx="4809744" cy="320040"/>
           </a:xfrm>
           <a:prstGeom prst="rect">
             <a:avLst/>
@@ -6582,7 +6582,7 @@
                 <a:ea typeface="Arial" pitchFamily="34" charset="-122"/>
                 <a:cs typeface="Arial" pitchFamily="34" charset="-120"/>
               </a:rPr>
-              <a:t>Historial y Supervisor</a:t>
+              <a:t>Baja de stock</a:t>
             </a:r>
             <a:endParaRPr lang="en-US" sz="1350" dirty="0"/>
           </a:p>
@@ -6596,8 +6596,8 @@
         </p:nvSpPr>
         <p:spPr>
           <a:xfrm>
-            <a:off x="8165592" y="3035808"/>
-            <a:ext cx="3035808" cy="640080"/>
+            <a:off x="960120" y="4983480"/>
+            <a:ext cx="4809744" cy="640080"/>
           </a:xfrm>
           <a:prstGeom prst="rect">
             <a:avLst/>
@@ -6624,7 +6624,7 @@
                 <a:ea typeface="Calibri" pitchFamily="34" charset="-122"/>
                 <a:cs typeface="Calibri" pitchFamily="34" charset="-120"/>
               </a:rPr>
-              <a:t>Ninguna propuesta los menciona.</a:t>
+              <a:t>Cuándo se envía la novedad y cuándo no.</a:t>
             </a:r>
             <a:endParaRPr lang="en-US" sz="1050" dirty="0"/>
           </a:p>
@@ -6638,8 +6638,8 @@
         </p:nvSpPr>
         <p:spPr>
           <a:xfrm>
-            <a:off x="777240" y="3995928"/>
-            <a:ext cx="3401568" cy="1691640"/>
+            <a:off x="6208776" y="4050792"/>
+            <a:ext cx="5175504" cy="1691640"/>
           </a:xfrm>
           <a:prstGeom prst="roundRect">
             <a:avLst>
@@ -6660,7 +6660,7 @@
         </p:nvSpPr>
         <p:spPr>
           <a:xfrm>
-            <a:off x="960120" y="4160520"/>
+            <a:off x="6391656" y="4215384"/>
             <a:ext cx="347472" cy="347472"/>
           </a:xfrm>
           <a:prstGeom prst="ellipse">
@@ -6680,7 +6680,7 @@
         </p:nvSpPr>
         <p:spPr>
           <a:xfrm>
-            <a:off x="960120" y="4160520"/>
+            <a:off x="6391656" y="4215384"/>
             <a:ext cx="347472" cy="347472"/>
           </a:xfrm>
           <a:prstGeom prst="rect">
@@ -6719,8 +6719,8 @@
         </p:nvSpPr>
         <p:spPr>
           <a:xfrm>
-            <a:off x="960120" y="4617720"/>
-            <a:ext cx="3035808" cy="320040"/>
+            <a:off x="6391656" y="4672584"/>
+            <a:ext cx="4809744" cy="320040"/>
           </a:xfrm>
           <a:prstGeom prst="rect">
             <a:avLst/>
@@ -6744,7 +6744,7 @@
                 <a:ea typeface="Arial" pitchFamily="34" charset="-122"/>
                 <a:cs typeface="Arial" pitchFamily="34" charset="-120"/>
               </a:rPr>
-              <a:t>Baja de stock</a:t>
+              <a:t>Devolución</a:t>
             </a:r>
             <a:endParaRPr lang="en-US" sz="1350" dirty="0"/>
           </a:p>
@@ -6758,170 +6758,8 @@
         </p:nvSpPr>
         <p:spPr>
           <a:xfrm>
-            <a:off x="960120" y="4928616"/>
-            <a:ext cx="3035808" cy="640080"/>
-          </a:xfrm>
-          <a:prstGeom prst="rect">
-            <a:avLst/>
-          </a:prstGeom>
-          <a:noFill/>
-          <a:ln/>
-        </p:spPr>
-        <p:txBody>
-          <a:bodyPr wrap="square" lIns="0" tIns="0" rIns="0" bIns="0" rtlCol="0" anchor="ctr"/>
-          <a:lstStyle/>
-          <a:p>
-            <a:pPr indent="0" marL="0">
-              <a:lnSpc>
-                <a:spcPct val="120000"/>
-              </a:lnSpc>
-              <a:buNone/>
-            </a:pPr>
-            <a:r>
-              <a:rPr lang="en-US" sz="1050" dirty="0">
-                <a:solidFill>
-                  <a:srgbClr val="49454F"/>
-                </a:solidFill>
-                <a:latin typeface="Calibri" pitchFamily="34" charset="0"/>
-                <a:ea typeface="Calibri" pitchFamily="34" charset="-122"/>
-                <a:cs typeface="Calibri" pitchFamily="34" charset="-120"/>
-              </a:rPr>
-              <a:t>Cuándo se envía la novedad y cuándo no.</a:t>
-            </a:r>
-            <a:endParaRPr lang="en-US" sz="1050" dirty="0"/>
-          </a:p>
-        </p:txBody>
-      </p:sp>
-      <p:sp>
-        <p:nvSpPr>
-          <p:cNvPr id="30" name="Shape 28"/>
-          <p:cNvSpPr/>
-          <p:nvPr/>
-        </p:nvSpPr>
-        <p:spPr>
-          <a:xfrm>
-            <a:off x="4379976" y="3995928"/>
-            <a:ext cx="3401568" cy="1691640"/>
-          </a:xfrm>
-          <a:prstGeom prst="roundRect">
-            <a:avLst>
-              <a:gd name="adj" fmla="val 3784"/>
-            </a:avLst>
-          </a:prstGeom>
-          <a:solidFill>
-            <a:srgbClr val="F2F2F2"/>
-          </a:solidFill>
-          <a:ln/>
-        </p:spPr>
-      </p:sp>
-      <p:sp>
-        <p:nvSpPr>
-          <p:cNvPr id="31" name="Shape 29"/>
-          <p:cNvSpPr/>
-          <p:nvPr/>
-        </p:nvSpPr>
-        <p:spPr>
-          <a:xfrm>
-            <a:off x="4562856" y="4160520"/>
-            <a:ext cx="347472" cy="347472"/>
-          </a:xfrm>
-          <a:prstGeom prst="ellipse">
-            <a:avLst/>
-          </a:prstGeom>
-          <a:solidFill>
-            <a:srgbClr val="FFCE00"/>
-          </a:solidFill>
-          <a:ln/>
-        </p:spPr>
-      </p:sp>
-      <p:sp>
-        <p:nvSpPr>
-          <p:cNvPr id="32" name="Text 30"/>
-          <p:cNvSpPr txBox="1"/>
-          <p:nvPr/>
-        </p:nvSpPr>
-        <p:spPr>
-          <a:xfrm>
-            <a:off x="4562856" y="4160520"/>
-            <a:ext cx="347472" cy="347472"/>
-          </a:xfrm>
-          <a:prstGeom prst="rect">
-            <a:avLst/>
-          </a:prstGeom>
-          <a:noFill/>
-          <a:ln/>
-        </p:spPr>
-        <p:txBody>
-          <a:bodyPr wrap="square" lIns="0" tIns="0" rIns="0" bIns="0" rtlCol="0" anchor="ctr"/>
-          <a:lstStyle/>
-          <a:p>
-            <a:pPr algn="ctr" indent="0" marL="0">
-              <a:buNone/>
-            </a:pPr>
-            <a:r>
-              <a:rPr lang="en-US" sz="1400" b="1" dirty="0">
-                <a:solidFill>
-                  <a:srgbClr val="152663"/>
-                </a:solidFill>
-                <a:latin typeface="Arial" pitchFamily="34" charset="0"/>
-                <a:ea typeface="Arial" pitchFamily="34" charset="-122"/>
-                <a:cs typeface="Arial" pitchFamily="34" charset="-120"/>
-              </a:rPr>
-              <a:t>?</a:t>
-            </a:r>
-            <a:endParaRPr lang="en-US" sz="1400" dirty="0"/>
-          </a:p>
-        </p:txBody>
-      </p:sp>
-      <p:sp>
-        <p:nvSpPr>
-          <p:cNvPr id="33" name="Text 31"/>
-          <p:cNvSpPr txBox="1"/>
-          <p:nvPr/>
-        </p:nvSpPr>
-        <p:spPr>
-          <a:xfrm>
-            <a:off x="4562856" y="4617720"/>
-            <a:ext cx="3035808" cy="320040"/>
-          </a:xfrm>
-          <a:prstGeom prst="rect">
-            <a:avLst/>
-          </a:prstGeom>
-          <a:noFill/>
-          <a:ln/>
-        </p:spPr>
-        <p:txBody>
-          <a:bodyPr wrap="square" lIns="0" tIns="0" rIns="0" bIns="0" rtlCol="0" anchor="ctr"/>
-          <a:lstStyle/>
-          <a:p>
-            <a:pPr indent="0" marL="0">
-              <a:buNone/>
-            </a:pPr>
-            <a:r>
-              <a:rPr lang="en-US" sz="1350" b="1" dirty="0">
-                <a:solidFill>
-                  <a:srgbClr val="191919"/>
-                </a:solidFill>
-                <a:latin typeface="Arial" pitchFamily="34" charset="0"/>
-                <a:ea typeface="Arial" pitchFamily="34" charset="-122"/>
-                <a:cs typeface="Arial" pitchFamily="34" charset="-120"/>
-              </a:rPr>
-              <a:t>Devolución</a:t>
-            </a:r>
-            <a:endParaRPr lang="en-US" sz="1350" dirty="0"/>
-          </a:p>
-        </p:txBody>
-      </p:sp>
-      <p:sp>
-        <p:nvSpPr>
-          <p:cNvPr id="34" name="Text 32"/>
-          <p:cNvSpPr txBox="1"/>
-          <p:nvPr/>
-        </p:nvSpPr>
-        <p:spPr>
-          <a:xfrm>
-            <a:off x="4562856" y="4928616"/>
-            <a:ext cx="3035808" cy="640080"/>
+            <a:off x="6391656" y="4983480"/>
+            <a:ext cx="4809744" cy="640080"/>
           </a:xfrm>
           <a:prstGeom prst="rect">
             <a:avLst/>
@@ -7123,7 +6961,7 @@
                 <a:ea typeface="Calibri" pitchFamily="34" charset="-122"/>
                 <a:cs typeface="Calibri" pitchFamily="34" charset="-120"/>
               </a:rPr>
-              <a:t>La Propuesta 1 ya tiene un prototipo navegable. La Propuesta 2 tiene el proceso mejor documentado. Ninguna está descartada.</a:t>
+              <a:t>Ambas propuestas siguen en evaluación, en igualdad de condiciones. Ninguna está descartada.</a:t>
             </a:r>
             <a:endParaRPr lang="en-US" sz="1700" dirty="0"/>
           </a:p>
@@ -10543,7 +10381,7 @@
                 <a:ea typeface="Arial" pitchFamily="34" charset="-122"/>
                 <a:cs typeface="Arial" pitchFamily="34" charset="-120"/>
               </a:rPr>
-              <a:t>Login</a:t>
+              <a:t>Identificación</a:t>
             </a:r>
             <a:endParaRPr lang="en-US" sz="1600" dirty="0"/>
           </a:p>
@@ -10618,27 +10456,24 @@
         </p:nvSpPr>
         <p:spPr>
           <a:xfrm>
-            <a:off x="777240" y="1463040"/>
-            <a:ext cx="4754880" cy="914400"/>
-          </a:xfrm>
-          <a:prstGeom prst="rect">
-            <a:avLst/>
-          </a:prstGeom>
-          <a:noFill/>
-          <a:ln/>
-        </p:spPr>
-        <p:txBody>
-          <a:bodyPr wrap="square" lIns="0" tIns="0" rIns="0" bIns="0" rtlCol="0" anchor="ctr"/>
-          <a:lstStyle/>
-          <a:p>
-            <a:pPr indent="0" marL="0">
-              <a:lnSpc>
-                <a:spcPct val="108000"/>
-              </a:lnSpc>
-              <a:buNone/>
-            </a:pPr>
-            <a:r>
-              <a:rPr lang="en-US" sz="2200" b="1" dirty="0">
+            <a:off x="777240" y="1508760"/>
+            <a:ext cx="6309360" cy="640080"/>
+          </a:xfrm>
+          <a:prstGeom prst="rect">
+            <a:avLst/>
+          </a:prstGeom>
+          <a:noFill/>
+          <a:ln/>
+        </p:spPr>
+        <p:txBody>
+          <a:bodyPr wrap="square" lIns="0" tIns="0" rIns="0" bIns="0" rtlCol="0" anchor="ctr"/>
+          <a:lstStyle/>
+          <a:p>
+            <a:pPr indent="0" marL="0">
+              <a:buNone/>
+            </a:pPr>
+            <a:r>
+              <a:rPr lang="en-US" sz="2400" b="1" dirty="0">
                 <a:solidFill>
                   <a:srgbClr val="191919"/>
                 </a:solidFill>
@@ -10648,7 +10483,7 @@
               </a:rPr>
               <a:t>Usuario y contraseña nominales</a:t>
             </a:r>
-            <a:endParaRPr lang="en-US" sz="2200" dirty="0"/>
+            <a:endParaRPr lang="en-US" sz="2400" dirty="0"/>
           </a:p>
         </p:txBody>
       </p:sp>
@@ -10660,8 +10495,8 @@
         </p:nvSpPr>
         <p:spPr>
           <a:xfrm>
-            <a:off x="777240" y="2423160"/>
-            <a:ext cx="4754880" cy="685800"/>
+            <a:off x="777240" y="2240280"/>
+            <a:ext cx="6309360" cy="822960"/>
           </a:xfrm>
           <a:prstGeom prst="rect">
             <a:avLst/>
@@ -10680,7 +10515,7 @@
               <a:buNone/>
             </a:pPr>
             <a:r>
-              <a:rPr lang="en-US" sz="1250" dirty="0">
+              <a:rPr lang="en-US" sz="1350" dirty="0">
                 <a:solidFill>
                   <a:srgbClr val="49454F"/>
                 </a:solidFill>
@@ -10690,262 +10525,19 @@
               </a:rPr>
               <a:t>El operador ingresa con su cuenta individual, no con un usuario compartido de sucursal.</a:t>
             </a:r>
-            <a:endParaRPr lang="en-US" sz="1250" dirty="0"/>
-          </a:p>
-        </p:txBody>
-      </p:sp>
-      <p:sp>
-        <p:nvSpPr>
-          <p:cNvPr id="11" name="Text 9"/>
-          <p:cNvSpPr txBox="1"/>
+            <a:endParaRPr lang="en-US" sz="1350" dirty="0"/>
+          </a:p>
+        </p:txBody>
+      </p:sp>
+      <p:sp>
+        <p:nvSpPr>
+          <p:cNvPr id="11" name="Shape 9"/>
+          <p:cNvSpPr/>
           <p:nvPr/>
         </p:nvSpPr>
         <p:spPr>
           <a:xfrm>
             <a:off x="777240" y="3200400"/>
-            <a:ext cx="4754880" cy="365760"/>
-          </a:xfrm>
-          <a:prstGeom prst="rect">
-            <a:avLst/>
-          </a:prstGeom>
-          <a:noFill/>
-          <a:ln/>
-        </p:spPr>
-        <p:txBody>
-          <a:bodyPr wrap="square" lIns="0" tIns="0" rIns="0" bIns="0" rtlCol="0" anchor="ctr"/>
-          <a:lstStyle/>
-          <a:p>
-            <a:pPr indent="0" marL="0">
-              <a:buNone/>
-            </a:pPr>
-            <a:r>
-              <a:rPr lang="en-US" sz="1250" b="1" dirty="0">
-                <a:solidFill>
-                  <a:srgbClr val="152663"/>
-                </a:solidFill>
-                <a:latin typeface="Calibri" pitchFamily="34" charset="0"/>
-                <a:ea typeface="Calibri" pitchFamily="34" charset="-122"/>
-                <a:cs typeface="Calibri" pitchFamily="34" charset="-120"/>
-              </a:rPr>
-              <a:t>•  </a:t>
-            </a:r>
-            <a:pPr indent="0" marL="0">
-              <a:buNone/>
-            </a:pPr>
-            <a:r>
-              <a:rPr lang="en-US" sz="1250" dirty="0">
-                <a:solidFill>
-                  <a:srgbClr val="49454F"/>
-                </a:solidFill>
-                <a:latin typeface="Calibri" pitchFamily="34" charset="0"/>
-                <a:ea typeface="Calibri" pitchFamily="34" charset="-122"/>
-                <a:cs typeface="Calibri" pitchFamily="34" charset="-120"/>
-              </a:rPr>
-              <a:t>Cada gestión queda </a:t>
-            </a:r>
-            <a:pPr indent="0" marL="0">
-              <a:buNone/>
-            </a:pPr>
-            <a:r>
-              <a:rPr lang="en-US" sz="1250" b="1" dirty="0">
-                <a:solidFill>
-                  <a:srgbClr val="191919"/>
-                </a:solidFill>
-                <a:latin typeface="Calibri" pitchFamily="34" charset="0"/>
-                <a:ea typeface="Calibri" pitchFamily="34" charset="-122"/>
-                <a:cs typeface="Calibri" pitchFamily="34" charset="-120"/>
-              </a:rPr>
-              <a:t>atribuida a una persona</a:t>
-            </a:r>
-            <a:pPr indent="0" marL="0">
-              <a:buNone/>
-            </a:pPr>
-            <a:r>
-              <a:rPr lang="en-US" sz="1250" dirty="0">
-                <a:solidFill>
-                  <a:srgbClr val="49454F"/>
-                </a:solidFill>
-                <a:latin typeface="Calibri" pitchFamily="34" charset="0"/>
-                <a:ea typeface="Calibri" pitchFamily="34" charset="-122"/>
-                <a:cs typeface="Calibri" pitchFamily="34" charset="-120"/>
-              </a:rPr>
-              <a:t>.</a:t>
-            </a:r>
-            <a:endParaRPr lang="en-US" sz="1250" dirty="0"/>
-          </a:p>
-        </p:txBody>
-      </p:sp>
-      <p:sp>
-        <p:nvSpPr>
-          <p:cNvPr id="12" name="Text 10"/>
-          <p:cNvSpPr txBox="1"/>
-          <p:nvPr/>
-        </p:nvSpPr>
-        <p:spPr>
-          <a:xfrm>
-            <a:off x="777240" y="3584448"/>
-            <a:ext cx="4754880" cy="365760"/>
-          </a:xfrm>
-          <a:prstGeom prst="rect">
-            <a:avLst/>
-          </a:prstGeom>
-          <a:noFill/>
-          <a:ln/>
-        </p:spPr>
-        <p:txBody>
-          <a:bodyPr wrap="square" lIns="0" tIns="0" rIns="0" bIns="0" rtlCol="0" anchor="ctr"/>
-          <a:lstStyle/>
-          <a:p>
-            <a:pPr indent="0" marL="0">
-              <a:buNone/>
-            </a:pPr>
-            <a:r>
-              <a:rPr lang="en-US" sz="1250" b="1" dirty="0">
-                <a:solidFill>
-                  <a:srgbClr val="152663"/>
-                </a:solidFill>
-                <a:latin typeface="Calibri" pitchFamily="34" charset="0"/>
-                <a:ea typeface="Calibri" pitchFamily="34" charset="-122"/>
-                <a:cs typeface="Calibri" pitchFamily="34" charset="-120"/>
-              </a:rPr>
-              <a:t>•  </a:t>
-            </a:r>
-            <a:pPr indent="0" marL="0">
-              <a:buNone/>
-            </a:pPr>
-            <a:r>
-              <a:rPr lang="en-US" sz="1250" dirty="0">
-                <a:solidFill>
-                  <a:srgbClr val="49454F"/>
-                </a:solidFill>
-                <a:latin typeface="Calibri" pitchFamily="34" charset="0"/>
-                <a:ea typeface="Calibri" pitchFamily="34" charset="-122"/>
-                <a:cs typeface="Calibri" pitchFamily="34" charset="-120"/>
-              </a:rPr>
-              <a:t>Requiere </a:t>
-            </a:r>
-            <a:pPr indent="0" marL="0">
-              <a:buNone/>
-            </a:pPr>
-            <a:r>
-              <a:rPr lang="en-US" sz="1250" b="1" dirty="0">
-                <a:solidFill>
-                  <a:srgbClr val="191919"/>
-                </a:solidFill>
-                <a:latin typeface="Calibri" pitchFamily="34" charset="0"/>
-                <a:ea typeface="Calibri" pitchFamily="34" charset="-122"/>
-                <a:cs typeface="Calibri" pitchFamily="34" charset="-120"/>
-              </a:rPr>
-              <a:t>ABM de usuarios</a:t>
-            </a:r>
-            <a:pPr indent="0" marL="0">
-              <a:buNone/>
-            </a:pPr>
-            <a:r>
-              <a:rPr lang="en-US" sz="1250" dirty="0">
-                <a:solidFill>
-                  <a:srgbClr val="49454F"/>
-                </a:solidFill>
-                <a:latin typeface="Calibri" pitchFamily="34" charset="0"/>
-                <a:ea typeface="Calibri" pitchFamily="34" charset="-122"/>
-                <a:cs typeface="Calibri" pitchFamily="34" charset="-120"/>
-              </a:rPr>
-              <a:t> con unidad de negocio.</a:t>
-            </a:r>
-            <a:endParaRPr lang="en-US" sz="1250" dirty="0"/>
-          </a:p>
-        </p:txBody>
-      </p:sp>
-      <p:sp>
-        <p:nvSpPr>
-          <p:cNvPr id="13" name="Text 11"/>
-          <p:cNvSpPr txBox="1"/>
-          <p:nvPr/>
-        </p:nvSpPr>
-        <p:spPr>
-          <a:xfrm>
-            <a:off x="777240" y="3968496"/>
-            <a:ext cx="4754880" cy="365760"/>
-          </a:xfrm>
-          <a:prstGeom prst="rect">
-            <a:avLst/>
-          </a:prstGeom>
-          <a:noFill/>
-          <a:ln/>
-        </p:spPr>
-        <p:txBody>
-          <a:bodyPr wrap="square" lIns="0" tIns="0" rIns="0" bIns="0" rtlCol="0" anchor="ctr"/>
-          <a:lstStyle/>
-          <a:p>
-            <a:pPr indent="0" marL="0">
-              <a:buNone/>
-            </a:pPr>
-            <a:r>
-              <a:rPr lang="en-US" sz="1250" b="1" dirty="0">
-                <a:solidFill>
-                  <a:srgbClr val="152663"/>
-                </a:solidFill>
-                <a:latin typeface="Calibri" pitchFamily="34" charset="0"/>
-                <a:ea typeface="Calibri" pitchFamily="34" charset="-122"/>
-                <a:cs typeface="Calibri" pitchFamily="34" charset="-120"/>
-              </a:rPr>
-              <a:t>•  </a:t>
-            </a:r>
-            <a:pPr indent="0" marL="0">
-              <a:buNone/>
-            </a:pPr>
-            <a:r>
-              <a:rPr lang="en-US" sz="1250" dirty="0">
-                <a:solidFill>
-                  <a:srgbClr val="49454F"/>
-                </a:solidFill>
-                <a:latin typeface="Calibri" pitchFamily="34" charset="0"/>
-                <a:ea typeface="Calibri" pitchFamily="34" charset="-122"/>
-                <a:cs typeface="Calibri" pitchFamily="34" charset="-120"/>
-              </a:rPr>
-              <a:t>Requiere </a:t>
-            </a:r>
-            <a:pPr indent="0" marL="0">
-              <a:buNone/>
-            </a:pPr>
-            <a:r>
-              <a:rPr lang="en-US" sz="1250" b="1" dirty="0">
-                <a:solidFill>
-                  <a:srgbClr val="191919"/>
-                </a:solidFill>
-                <a:latin typeface="Calibri" pitchFamily="34" charset="0"/>
-                <a:ea typeface="Calibri" pitchFamily="34" charset="-122"/>
-                <a:cs typeface="Calibri" pitchFamily="34" charset="-120"/>
-              </a:rPr>
-              <a:t>ABM de roles y perfiles</a:t>
-            </a:r>
-            <a:pPr indent="0" marL="0">
-              <a:buNone/>
-            </a:pPr>
-            <a:r>
-              <a:rPr lang="en-US" sz="1250" dirty="0">
-                <a:solidFill>
-                  <a:srgbClr val="49454F"/>
-                </a:solidFill>
-                <a:latin typeface="Calibri" pitchFamily="34" charset="0"/>
-                <a:ea typeface="Calibri" pitchFamily="34" charset="-122"/>
-                <a:cs typeface="Calibri" pitchFamily="34" charset="-120"/>
-              </a:rPr>
-              <a:t>.</a:t>
-            </a:r>
-            <a:endParaRPr lang="en-US" sz="1250" dirty="0"/>
-          </a:p>
-        </p:txBody>
-      </p:sp>
-      <p:sp>
-        <p:nvSpPr>
-          <p:cNvPr id="14" name="Shape 12"/>
-          <p:cNvSpPr/>
-          <p:nvPr/>
-        </p:nvSpPr>
-        <p:spPr>
-          <a:xfrm>
-            <a:off x="777240" y="4526280"/>
             <a:ext cx="1188720" cy="329184"/>
           </a:xfrm>
           <a:prstGeom prst="roundRect">
@@ -10961,13 +10553,13 @@
       </p:sp>
       <p:sp>
         <p:nvSpPr>
-          <p:cNvPr id="15" name="Text 13"/>
-          <p:cNvSpPr txBox="1"/>
-          <p:nvPr/>
-        </p:nvSpPr>
-        <p:spPr>
-          <a:xfrm>
-            <a:off x="777240" y="4526280"/>
+          <p:cNvPr id="12" name="Text 10"/>
+          <p:cNvSpPr txBox="1"/>
+          <p:nvPr/>
+        </p:nvSpPr>
+        <p:spPr>
+          <a:xfrm>
+            <a:off x="777240" y="3200400"/>
             <a:ext cx="1188720" cy="329184"/>
           </a:xfrm>
           <a:prstGeom prst="rect">
@@ -11000,612 +10592,226 @@
       </p:sp>
       <p:sp>
         <p:nvSpPr>
-          <p:cNvPr id="16" name="Shape 14"/>
+          <p:cNvPr id="13" name="Shape 11"/>
           <p:cNvSpPr/>
           <p:nvPr/>
         </p:nvSpPr>
         <p:spPr>
           <a:xfrm>
-            <a:off x="6035040" y="1051560"/>
-            <a:ext cx="5486400" cy="5074920"/>
+            <a:off x="7452360" y="1508760"/>
+            <a:ext cx="3977640" cy="502920"/>
           </a:xfrm>
           <a:prstGeom prst="roundRect">
             <a:avLst>
-              <a:gd name="adj" fmla="val 2162"/>
+              <a:gd name="adj" fmla="val 14545"/>
             </a:avLst>
           </a:prstGeom>
           <a:solidFill>
-            <a:srgbClr val="191919"/>
-          </a:solidFill>
-          <a:ln/>
-          <a:effectLst>
-            <a:outerShdw sx="100000" sy="100000" kx="0" ky="0" algn="bl" rotWithShape="0" blurRad="152400" dist="76200" dir="5400000">
-              <a:srgbClr val="152663">
-                <a:alpha val="35000"/>
-              </a:srgbClr>
-            </a:outerShdw>
-          </a:effectLst>
-        </p:spPr>
-      </p:sp>
-      <p:sp>
-        <p:nvSpPr>
-          <p:cNvPr id="17" name="Shape 15"/>
-          <p:cNvSpPr/>
-          <p:nvPr/>
-        </p:nvSpPr>
-        <p:spPr>
-          <a:xfrm>
-            <a:off x="6117336" y="1133856"/>
-            <a:ext cx="5321808" cy="4910328"/>
-          </a:xfrm>
-          <a:prstGeom prst="roundRect">
-            <a:avLst>
-              <a:gd name="adj" fmla="val 931"/>
-            </a:avLst>
-          </a:prstGeom>
-          <a:solidFill>
-            <a:srgbClr val="FFFFFF"/>
-          </a:solidFill>
-          <a:ln/>
-        </p:spPr>
-      </p:sp>
-      <p:sp>
-        <p:nvSpPr>
-          <p:cNvPr id="18" name="Shape 16"/>
-          <p:cNvSpPr/>
-          <p:nvPr/>
-        </p:nvSpPr>
-        <p:spPr>
-          <a:xfrm>
-            <a:off x="8522208" y="1453896"/>
-            <a:ext cx="512064" cy="512064"/>
-          </a:xfrm>
-          <a:prstGeom prst="ellipse">
-            <a:avLst/>
-          </a:prstGeom>
-          <a:solidFill>
-            <a:srgbClr val="FFFFFF"/>
-          </a:solidFill>
-          <a:ln w="19050">
-            <a:solidFill>
-              <a:srgbClr val="191919"/>
-            </a:solidFill>
-            <a:prstDash val="solid"/>
-          </a:ln>
-        </p:spPr>
-      </p:sp>
-      <p:sp>
-        <p:nvSpPr>
-          <p:cNvPr id="19" name="Text 17"/>
-          <p:cNvSpPr txBox="1"/>
-          <p:nvPr/>
-        </p:nvSpPr>
-        <p:spPr>
-          <a:xfrm>
-            <a:off x="8522208" y="1453896"/>
-            <a:ext cx="512064" cy="512064"/>
-          </a:xfrm>
-          <a:prstGeom prst="rect">
-            <a:avLst/>
-          </a:prstGeom>
-          <a:noFill/>
-          <a:ln/>
-        </p:spPr>
-        <p:txBody>
-          <a:bodyPr wrap="square" lIns="0" tIns="0" rIns="0" bIns="0" rtlCol="0" anchor="ctr"/>
-          <a:lstStyle/>
-          <a:p>
-            <a:pPr algn="ctr" indent="0" marL="0">
-              <a:buNone/>
-            </a:pPr>
-            <a:r>
-              <a:rPr lang="en-US" sz="1100" b="1" dirty="0">
-                <a:solidFill>
-                  <a:srgbClr val="191919"/>
-                </a:solidFill>
-                <a:latin typeface="Arial" pitchFamily="34" charset="0"/>
-                <a:ea typeface="Arial" pitchFamily="34" charset="-122"/>
-                <a:cs typeface="Arial" pitchFamily="34" charset="-120"/>
-              </a:rPr>
-              <a:t>CA</a:t>
-            </a:r>
-            <a:endParaRPr lang="en-US" sz="1100" dirty="0"/>
-          </a:p>
-        </p:txBody>
-      </p:sp>
-      <p:sp>
-        <p:nvSpPr>
-          <p:cNvPr id="20" name="Text 18"/>
-          <p:cNvSpPr txBox="1"/>
-          <p:nvPr/>
-        </p:nvSpPr>
-        <p:spPr>
-          <a:xfrm>
-            <a:off x="7406640" y="2139696"/>
-            <a:ext cx="2743200" cy="228600"/>
-          </a:xfrm>
-          <a:prstGeom prst="rect">
-            <a:avLst/>
-          </a:prstGeom>
-          <a:noFill/>
-          <a:ln/>
-        </p:spPr>
-        <p:txBody>
-          <a:bodyPr wrap="square" lIns="0" tIns="0" rIns="0" bIns="0" rtlCol="0" anchor="ctr"/>
-          <a:lstStyle/>
-          <a:p>
-            <a:pPr algn="ctr" indent="0" marL="0">
-              <a:buNone/>
-            </a:pPr>
-            <a:r>
-              <a:rPr lang="en-US" sz="700" b="1" spc="100" kern="0" dirty="0">
-                <a:solidFill>
-                  <a:srgbClr val="79747E"/>
-                </a:solidFill>
-                <a:latin typeface="Arial" pitchFamily="34" charset="0"/>
-                <a:ea typeface="Arial" pitchFamily="34" charset="-122"/>
-                <a:cs typeface="Arial" pitchFamily="34" charset="-120"/>
-              </a:rPr>
-              <a:t>CORREO ARGENTINO · PROTOTIPO FUNCIONAL</a:t>
-            </a:r>
-            <a:endParaRPr lang="en-US" sz="700" dirty="0"/>
-          </a:p>
-        </p:txBody>
-      </p:sp>
-      <p:sp>
-        <p:nvSpPr>
-          <p:cNvPr id="21" name="Text 19"/>
-          <p:cNvSpPr txBox="1"/>
-          <p:nvPr/>
-        </p:nvSpPr>
-        <p:spPr>
-          <a:xfrm>
-            <a:off x="7406640" y="2414016"/>
-            <a:ext cx="2743200" cy="274320"/>
-          </a:xfrm>
-          <a:prstGeom prst="rect">
-            <a:avLst/>
-          </a:prstGeom>
-          <a:noFill/>
-          <a:ln/>
-        </p:spPr>
-        <p:txBody>
-          <a:bodyPr wrap="square" lIns="0" tIns="0" rIns="0" bIns="0" rtlCol="0" anchor="ctr"/>
-          <a:lstStyle/>
-          <a:p>
-            <a:pPr algn="ctr" indent="0" marL="0">
-              <a:buNone/>
-            </a:pPr>
-            <a:r>
-              <a:rPr lang="en-US" sz="1300" dirty="0">
-                <a:solidFill>
-                  <a:srgbClr val="191919"/>
-                </a:solidFill>
-                <a:latin typeface="Arial" pitchFamily="34" charset="0"/>
-                <a:ea typeface="Arial" pitchFamily="34" charset="-122"/>
-                <a:cs typeface="Arial" pitchFamily="34" charset="-120"/>
-              </a:rPr>
-              <a:t>Entrega en sucursal</a:t>
-            </a:r>
-            <a:endParaRPr lang="en-US" sz="1300" dirty="0"/>
-          </a:p>
-        </p:txBody>
-      </p:sp>
-      <p:sp>
-        <p:nvSpPr>
-          <p:cNvPr id="22" name="Text 20"/>
-          <p:cNvSpPr txBox="1"/>
-          <p:nvPr/>
-        </p:nvSpPr>
-        <p:spPr>
-          <a:xfrm>
-            <a:off x="7406640" y="2871216"/>
-            <a:ext cx="2743200" cy="201168"/>
-          </a:xfrm>
-          <a:prstGeom prst="rect">
-            <a:avLst/>
-          </a:prstGeom>
-          <a:noFill/>
-          <a:ln/>
-        </p:spPr>
-        <p:txBody>
-          <a:bodyPr wrap="square" lIns="0" tIns="0" rIns="0" bIns="0" rtlCol="0" anchor="ctr"/>
-          <a:lstStyle/>
-          <a:p>
-            <a:pPr indent="0" marL="0">
-              <a:buNone/>
-            </a:pPr>
-            <a:r>
-              <a:rPr lang="en-US" sz="800" b="1" dirty="0">
-                <a:solidFill>
-                  <a:srgbClr val="191919"/>
+            <a:srgbClr val="F2F2F2"/>
+          </a:solidFill>
+          <a:ln/>
+        </p:spPr>
+      </p:sp>
+      <p:sp>
+        <p:nvSpPr>
+          <p:cNvPr id="14" name="Text 12"/>
+          <p:cNvSpPr txBox="1"/>
+          <p:nvPr/>
+        </p:nvSpPr>
+        <p:spPr>
+          <a:xfrm>
+            <a:off x="7616952" y="1508760"/>
+            <a:ext cx="3685032" cy="502920"/>
+          </a:xfrm>
+          <a:prstGeom prst="rect">
+            <a:avLst/>
+          </a:prstGeom>
+          <a:noFill/>
+          <a:ln/>
+        </p:spPr>
+        <p:txBody>
+          <a:bodyPr wrap="square" lIns="0" tIns="0" rIns="0" bIns="0" rtlCol="0" anchor="ctr"/>
+          <a:lstStyle/>
+          <a:p>
+            <a:pPr indent="0" marL="0">
+              <a:buNone/>
+            </a:pPr>
+            <a:r>
+              <a:rPr lang="en-US" sz="1300" b="1" dirty="0">
+                <a:solidFill>
+                  <a:srgbClr val="10B981"/>
                 </a:solidFill>
                 <a:latin typeface="Calibri" pitchFamily="34" charset="0"/>
                 <a:ea typeface="Calibri" pitchFamily="34" charset="-122"/>
                 <a:cs typeface="Calibri" pitchFamily="34" charset="-120"/>
               </a:rPr>
-              <a:t>Usuario *</a:t>
-            </a:r>
-            <a:endParaRPr lang="en-US" sz="800" dirty="0"/>
-          </a:p>
-        </p:txBody>
-      </p:sp>
-      <p:sp>
-        <p:nvSpPr>
-          <p:cNvPr id="23" name="Shape 21"/>
-          <p:cNvSpPr/>
-          <p:nvPr/>
-        </p:nvSpPr>
-        <p:spPr>
-          <a:xfrm>
-            <a:off x="7406640" y="3090672"/>
-            <a:ext cx="2743200" cy="292608"/>
-          </a:xfrm>
-          <a:prstGeom prst="rect">
-            <a:avLst/>
-          </a:prstGeom>
-          <a:solidFill>
-            <a:srgbClr val="FFFFFF"/>
-          </a:solidFill>
-          <a:ln w="12700">
-            <a:solidFill>
-              <a:srgbClr val="DFE3EA"/>
-            </a:solidFill>
-            <a:prstDash val="solid"/>
-          </a:ln>
-        </p:spPr>
-      </p:sp>
-      <p:sp>
-        <p:nvSpPr>
-          <p:cNvPr id="24" name="Text 22"/>
-          <p:cNvSpPr txBox="1"/>
-          <p:nvPr/>
-        </p:nvSpPr>
-        <p:spPr>
-          <a:xfrm>
-            <a:off x="7406640" y="3493008"/>
-            <a:ext cx="2743200" cy="201168"/>
-          </a:xfrm>
-          <a:prstGeom prst="rect">
-            <a:avLst/>
-          </a:prstGeom>
-          <a:noFill/>
-          <a:ln/>
-        </p:spPr>
-        <p:txBody>
-          <a:bodyPr wrap="square" lIns="0" tIns="0" rIns="0" bIns="0" rtlCol="0" anchor="ctr"/>
-          <a:lstStyle/>
-          <a:p>
-            <a:pPr indent="0" marL="0">
-              <a:buNone/>
-            </a:pPr>
-            <a:r>
-              <a:rPr lang="en-US" sz="800" b="1" dirty="0">
-                <a:solidFill>
-                  <a:srgbClr val="191919"/>
+              <a:t>✓  </a:t>
+            </a:r>
+            <a:pPr indent="0" marL="0">
+              <a:buNone/>
+            </a:pPr>
+            <a:r>
+              <a:rPr lang="en-US" sz="1300" b="1" dirty="0">
+                <a:solidFill>
+                  <a:srgbClr val="152663"/>
                 </a:solidFill>
                 <a:latin typeface="Calibri" pitchFamily="34" charset="0"/>
                 <a:ea typeface="Calibri" pitchFamily="34" charset="-122"/>
                 <a:cs typeface="Calibri" pitchFamily="34" charset="-120"/>
               </a:rPr>
-              <a:t>Contraseña *</a:t>
-            </a:r>
-            <a:endParaRPr lang="en-US" sz="800" dirty="0"/>
-          </a:p>
-        </p:txBody>
-      </p:sp>
-      <p:sp>
-        <p:nvSpPr>
-          <p:cNvPr id="25" name="Shape 23"/>
+              <a:t>Cada gestión queda atribuida a una persona</a:t>
+            </a:r>
+            <a:endParaRPr lang="en-US" sz="1300" dirty="0"/>
+          </a:p>
+        </p:txBody>
+      </p:sp>
+      <p:sp>
+        <p:nvSpPr>
+          <p:cNvPr id="15" name="Shape 13"/>
           <p:cNvSpPr/>
           <p:nvPr/>
         </p:nvSpPr>
         <p:spPr>
           <a:xfrm>
-            <a:off x="7406640" y="3712464"/>
-            <a:ext cx="2743200" cy="292608"/>
-          </a:xfrm>
-          <a:prstGeom prst="rect">
-            <a:avLst/>
-          </a:prstGeom>
-          <a:solidFill>
-            <a:srgbClr val="FFFFFF"/>
-          </a:solidFill>
-          <a:ln w="12700">
-            <a:solidFill>
-              <a:srgbClr val="DFE3EA"/>
-            </a:solidFill>
-            <a:prstDash val="solid"/>
-          </a:ln>
-        </p:spPr>
-      </p:sp>
-      <p:sp>
-        <p:nvSpPr>
-          <p:cNvPr id="26" name="Shape 24"/>
+            <a:off x="7452360" y="2157984"/>
+            <a:ext cx="3977640" cy="502920"/>
+          </a:xfrm>
+          <a:prstGeom prst="roundRect">
+            <a:avLst>
+              <a:gd name="adj" fmla="val 14545"/>
+            </a:avLst>
+          </a:prstGeom>
+          <a:solidFill>
+            <a:srgbClr val="F2F2F2"/>
+          </a:solidFill>
+          <a:ln/>
+        </p:spPr>
+      </p:sp>
+      <p:sp>
+        <p:nvSpPr>
+          <p:cNvPr id="16" name="Text 14"/>
+          <p:cNvSpPr txBox="1"/>
+          <p:nvPr/>
+        </p:nvSpPr>
+        <p:spPr>
+          <a:xfrm>
+            <a:off x="7616952" y="2157984"/>
+            <a:ext cx="3685032" cy="502920"/>
+          </a:xfrm>
+          <a:prstGeom prst="rect">
+            <a:avLst/>
+          </a:prstGeom>
+          <a:noFill/>
+          <a:ln/>
+        </p:spPr>
+        <p:txBody>
+          <a:bodyPr wrap="square" lIns="0" tIns="0" rIns="0" bIns="0" rtlCol="0" anchor="ctr"/>
+          <a:lstStyle/>
+          <a:p>
+            <a:pPr indent="0" marL="0">
+              <a:buNone/>
+            </a:pPr>
+            <a:r>
+              <a:rPr lang="en-US" sz="1300" b="1" dirty="0">
+                <a:solidFill>
+                  <a:srgbClr val="10B981"/>
+                </a:solidFill>
+                <a:latin typeface="Calibri" pitchFamily="34" charset="0"/>
+                <a:ea typeface="Calibri" pitchFamily="34" charset="-122"/>
+                <a:cs typeface="Calibri" pitchFamily="34" charset="-120"/>
+              </a:rPr>
+              <a:t>✓  </a:t>
+            </a:r>
+            <a:pPr indent="0" marL="0">
+              <a:buNone/>
+            </a:pPr>
+            <a:r>
+              <a:rPr lang="en-US" sz="1300" b="1" dirty="0">
+                <a:solidFill>
+                  <a:srgbClr val="152663"/>
+                </a:solidFill>
+                <a:latin typeface="Calibri" pitchFamily="34" charset="0"/>
+                <a:ea typeface="Calibri" pitchFamily="34" charset="-122"/>
+                <a:cs typeface="Calibri" pitchFamily="34" charset="-120"/>
+              </a:rPr>
+              <a:t>Requiere ABM de usuarios con unidad de negocio</a:t>
+            </a:r>
+            <a:endParaRPr lang="en-US" sz="1300" dirty="0"/>
+          </a:p>
+        </p:txBody>
+      </p:sp>
+      <p:sp>
+        <p:nvSpPr>
+          <p:cNvPr id="17" name="Shape 15"/>
           <p:cNvSpPr/>
           <p:nvPr/>
         </p:nvSpPr>
         <p:spPr>
           <a:xfrm>
-            <a:off x="7406640" y="4114800"/>
-            <a:ext cx="2743200" cy="310896"/>
-          </a:xfrm>
-          <a:prstGeom prst="rect">
-            <a:avLst/>
-          </a:prstGeom>
-          <a:solidFill>
-            <a:srgbClr val="191919"/>
-          </a:solidFill>
-          <a:ln/>
-        </p:spPr>
-      </p:sp>
-      <p:sp>
-        <p:nvSpPr>
-          <p:cNvPr id="27" name="Text 25"/>
-          <p:cNvSpPr txBox="1"/>
-          <p:nvPr/>
-        </p:nvSpPr>
-        <p:spPr>
-          <a:xfrm>
-            <a:off x="7406640" y="4114800"/>
-            <a:ext cx="2743200" cy="310896"/>
-          </a:xfrm>
-          <a:prstGeom prst="rect">
-            <a:avLst/>
-          </a:prstGeom>
-          <a:noFill/>
-          <a:ln/>
-        </p:spPr>
-        <p:txBody>
-          <a:bodyPr wrap="square" lIns="0" tIns="0" rIns="0" bIns="0" rtlCol="0" anchor="ctr"/>
-          <a:lstStyle/>
-          <a:p>
-            <a:pPr algn="ctr" indent="0" marL="0">
-              <a:buNone/>
-            </a:pPr>
-            <a:r>
-              <a:rPr lang="en-US" sz="1000" b="1" dirty="0">
-                <a:solidFill>
-                  <a:srgbClr val="FFFFFF"/>
-                </a:solidFill>
-                <a:latin typeface="Arial" pitchFamily="34" charset="0"/>
-                <a:ea typeface="Arial" pitchFamily="34" charset="-122"/>
-                <a:cs typeface="Arial" pitchFamily="34" charset="-120"/>
-              </a:rPr>
-              <a:t>Ingresar</a:t>
-            </a:r>
-            <a:endParaRPr lang="en-US" sz="1000" dirty="0"/>
-          </a:p>
-        </p:txBody>
-      </p:sp>
-      <p:sp>
-        <p:nvSpPr>
-          <p:cNvPr id="28" name="Text 26"/>
-          <p:cNvSpPr txBox="1"/>
-          <p:nvPr/>
-        </p:nvSpPr>
-        <p:spPr>
-          <a:xfrm>
-            <a:off x="7406640" y="4572000"/>
-            <a:ext cx="2743200" cy="182880"/>
-          </a:xfrm>
-          <a:prstGeom prst="rect">
-            <a:avLst/>
-          </a:prstGeom>
-          <a:noFill/>
-          <a:ln/>
-        </p:spPr>
-        <p:txBody>
-          <a:bodyPr wrap="square" lIns="0" tIns="0" rIns="0" bIns="0" rtlCol="0" anchor="ctr"/>
-          <a:lstStyle/>
-          <a:p>
-            <a:pPr indent="0" marL="0">
-              <a:buNone/>
-            </a:pPr>
-            <a:r>
-              <a:rPr lang="en-US" sz="650" b="1" spc="100" kern="0" dirty="0">
-                <a:solidFill>
-                  <a:srgbClr val="79747E"/>
-                </a:solidFill>
-                <a:latin typeface="Arial" pitchFamily="34" charset="0"/>
-                <a:ea typeface="Arial" pitchFamily="34" charset="-122"/>
-                <a:cs typeface="Arial" pitchFamily="34" charset="-120"/>
-              </a:rPr>
-              <a:t>ACCESOS DE PRUEBA (WIREFRAME)</a:t>
-            </a:r>
-            <a:endParaRPr lang="en-US" sz="650" dirty="0"/>
-          </a:p>
-        </p:txBody>
-      </p:sp>
-      <p:sp>
-        <p:nvSpPr>
-          <p:cNvPr id="29" name="Shape 27"/>
-          <p:cNvSpPr/>
-          <p:nvPr/>
-        </p:nvSpPr>
-        <p:spPr>
-          <a:xfrm>
-            <a:off x="7406640" y="4791456"/>
-            <a:ext cx="2743200" cy="274320"/>
-          </a:xfrm>
-          <a:prstGeom prst="rect">
-            <a:avLst/>
-          </a:prstGeom>
-          <a:solidFill>
-            <a:srgbClr val="FFFFFF"/>
-          </a:solidFill>
-          <a:ln w="12700">
-            <a:solidFill>
-              <a:srgbClr val="191919"/>
-            </a:solidFill>
-            <a:prstDash val="solid"/>
-          </a:ln>
-        </p:spPr>
-      </p:sp>
-      <p:sp>
-        <p:nvSpPr>
-          <p:cNvPr id="30" name="Text 28"/>
-          <p:cNvSpPr txBox="1"/>
-          <p:nvPr/>
-        </p:nvSpPr>
-        <p:spPr>
-          <a:xfrm>
-            <a:off x="7406640" y="4791456"/>
-            <a:ext cx="2743200" cy="274320"/>
-          </a:xfrm>
-          <a:prstGeom prst="rect">
-            <a:avLst/>
-          </a:prstGeom>
-          <a:noFill/>
-          <a:ln/>
-        </p:spPr>
-        <p:txBody>
-          <a:bodyPr wrap="square" lIns="0" tIns="0" rIns="0" bIns="0" rtlCol="0" anchor="ctr"/>
-          <a:lstStyle/>
-          <a:p>
-            <a:pPr algn="ctr" indent="0" marL="0">
-              <a:buNone/>
-            </a:pPr>
-            <a:r>
-              <a:rPr lang="en-US" sz="800" b="1" dirty="0">
-                <a:solidFill>
-                  <a:srgbClr val="191919"/>
-                </a:solidFill>
-                <a:latin typeface="Arial" pitchFamily="34" charset="0"/>
-                <a:ea typeface="Arial" pitchFamily="34" charset="-122"/>
-                <a:cs typeface="Arial" pitchFamily="34" charset="-120"/>
-              </a:rPr>
-              <a:t>Ingresar como Operador</a:t>
-            </a:r>
-            <a:endParaRPr lang="en-US" sz="800" dirty="0"/>
-          </a:p>
-        </p:txBody>
-      </p:sp>
-      <p:sp>
-        <p:nvSpPr>
-          <p:cNvPr id="31" name="Shape 29"/>
-          <p:cNvSpPr/>
-          <p:nvPr/>
-        </p:nvSpPr>
-        <p:spPr>
-          <a:xfrm>
-            <a:off x="7406640" y="5120640"/>
-            <a:ext cx="2743200" cy="274320"/>
-          </a:xfrm>
-          <a:prstGeom prst="rect">
-            <a:avLst/>
-          </a:prstGeom>
-          <a:solidFill>
-            <a:srgbClr val="FFFFFF"/>
-          </a:solidFill>
-          <a:ln w="12700">
-            <a:solidFill>
-              <a:srgbClr val="191919"/>
-            </a:solidFill>
-            <a:prstDash val="solid"/>
-          </a:ln>
-        </p:spPr>
-      </p:sp>
-      <p:sp>
-        <p:nvSpPr>
-          <p:cNvPr id="32" name="Text 30"/>
-          <p:cNvSpPr txBox="1"/>
-          <p:nvPr/>
-        </p:nvSpPr>
-        <p:spPr>
-          <a:xfrm>
-            <a:off x="7406640" y="5120640"/>
-            <a:ext cx="2743200" cy="274320"/>
-          </a:xfrm>
-          <a:prstGeom prst="rect">
-            <a:avLst/>
-          </a:prstGeom>
-          <a:noFill/>
-          <a:ln/>
-        </p:spPr>
-        <p:txBody>
-          <a:bodyPr wrap="square" lIns="0" tIns="0" rIns="0" bIns="0" rtlCol="0" anchor="ctr"/>
-          <a:lstStyle/>
-          <a:p>
-            <a:pPr algn="ctr" indent="0" marL="0">
-              <a:buNone/>
-            </a:pPr>
-            <a:r>
-              <a:rPr lang="en-US" sz="800" b="1" dirty="0">
-                <a:solidFill>
-                  <a:srgbClr val="191919"/>
-                </a:solidFill>
-                <a:latin typeface="Arial" pitchFamily="34" charset="0"/>
-                <a:ea typeface="Arial" pitchFamily="34" charset="-122"/>
-                <a:cs typeface="Arial" pitchFamily="34" charset="-120"/>
-              </a:rPr>
-              <a:t>Ingresar como Administrador</a:t>
-            </a:r>
-            <a:endParaRPr lang="en-US" sz="800" dirty="0"/>
-          </a:p>
-        </p:txBody>
-      </p:sp>
-      <p:sp>
-        <p:nvSpPr>
-          <p:cNvPr id="33" name="Shape 31"/>
-          <p:cNvSpPr/>
-          <p:nvPr/>
-        </p:nvSpPr>
-        <p:spPr>
-          <a:xfrm>
-            <a:off x="7406640" y="5449824"/>
-            <a:ext cx="2743200" cy="274320"/>
-          </a:xfrm>
-          <a:prstGeom prst="rect">
-            <a:avLst/>
-          </a:prstGeom>
-          <a:solidFill>
-            <a:srgbClr val="FFFFFF"/>
-          </a:solidFill>
-          <a:ln w="12700">
-            <a:solidFill>
-              <a:srgbClr val="191919"/>
-            </a:solidFill>
-            <a:prstDash val="solid"/>
-          </a:ln>
-        </p:spPr>
-      </p:sp>
-      <p:sp>
-        <p:nvSpPr>
-          <p:cNvPr id="34" name="Text 32"/>
-          <p:cNvSpPr txBox="1"/>
-          <p:nvPr/>
-        </p:nvSpPr>
-        <p:spPr>
-          <a:xfrm>
-            <a:off x="7406640" y="5449824"/>
-            <a:ext cx="2743200" cy="274320"/>
-          </a:xfrm>
-          <a:prstGeom prst="rect">
-            <a:avLst/>
-          </a:prstGeom>
-          <a:noFill/>
-          <a:ln/>
-        </p:spPr>
-        <p:txBody>
-          <a:bodyPr wrap="square" lIns="0" tIns="0" rIns="0" bIns="0" rtlCol="0" anchor="ctr"/>
-          <a:lstStyle/>
-          <a:p>
-            <a:pPr algn="ctr" indent="0" marL="0">
-              <a:buNone/>
-            </a:pPr>
-            <a:r>
-              <a:rPr lang="en-US" sz="800" b="1" dirty="0">
-                <a:solidFill>
-                  <a:srgbClr val="191919"/>
-                </a:solidFill>
-                <a:latin typeface="Arial" pitchFamily="34" charset="0"/>
-                <a:ea typeface="Arial" pitchFamily="34" charset="-122"/>
-                <a:cs typeface="Arial" pitchFamily="34" charset="-120"/>
-              </a:rPr>
-              <a:t>Ingresar como Supervisor</a:t>
-            </a:r>
-            <a:endParaRPr lang="en-US" sz="800" dirty="0"/>
+            <a:off x="7452360" y="2807208"/>
+            <a:ext cx="3977640" cy="502920"/>
+          </a:xfrm>
+          <a:prstGeom prst="roundRect">
+            <a:avLst>
+              <a:gd name="adj" fmla="val 14545"/>
+            </a:avLst>
+          </a:prstGeom>
+          <a:solidFill>
+            <a:srgbClr val="F2F2F2"/>
+          </a:solidFill>
+          <a:ln/>
+        </p:spPr>
+      </p:sp>
+      <p:sp>
+        <p:nvSpPr>
+          <p:cNvPr id="18" name="Text 16"/>
+          <p:cNvSpPr txBox="1"/>
+          <p:nvPr/>
+        </p:nvSpPr>
+        <p:spPr>
+          <a:xfrm>
+            <a:off x="7616952" y="2807208"/>
+            <a:ext cx="3685032" cy="502920"/>
+          </a:xfrm>
+          <a:prstGeom prst="rect">
+            <a:avLst/>
+          </a:prstGeom>
+          <a:noFill/>
+          <a:ln/>
+        </p:spPr>
+        <p:txBody>
+          <a:bodyPr wrap="square" lIns="0" tIns="0" rIns="0" bIns="0" rtlCol="0" anchor="ctr"/>
+          <a:lstStyle/>
+          <a:p>
+            <a:pPr indent="0" marL="0">
+              <a:buNone/>
+            </a:pPr>
+            <a:r>
+              <a:rPr lang="en-US" sz="1300" b="1" dirty="0">
+                <a:solidFill>
+                  <a:srgbClr val="10B981"/>
+                </a:solidFill>
+                <a:latin typeface="Calibri" pitchFamily="34" charset="0"/>
+                <a:ea typeface="Calibri" pitchFamily="34" charset="-122"/>
+                <a:cs typeface="Calibri" pitchFamily="34" charset="-120"/>
+              </a:rPr>
+              <a:t>✓  </a:t>
+            </a:r>
+            <a:pPr indent="0" marL="0">
+              <a:buNone/>
+            </a:pPr>
+            <a:r>
+              <a:rPr lang="en-US" sz="1300" b="1" dirty="0">
+                <a:solidFill>
+                  <a:srgbClr val="152663"/>
+                </a:solidFill>
+                <a:latin typeface="Calibri" pitchFamily="34" charset="0"/>
+                <a:ea typeface="Calibri" pitchFamily="34" charset="-122"/>
+                <a:cs typeface="Calibri" pitchFamily="34" charset="-120"/>
+              </a:rPr>
+              <a:t>Requiere ABM de roles y perfiles</a:t>
+            </a:r>
+            <a:endParaRPr lang="en-US" sz="1300" dirty="0"/>
           </a:p>
         </p:txBody>
       </p:sp>

</xml_diff>